<commit_message>
Record LOC-02's blank shallow-base column as confirmed "NO"
The LOC-02 field sheet leaves its shallow-base column blank. Rev P07
previously carried it as an open reading ("READ AS NOT AFFECTED ...
CONFIRM AT CUT LINE"); it is now confirmed NO and stated as settled on
the sheet, with the provenance kept — the column was blank, and the
confirmation is dated.

field_sheets.json records base: false with base_blank_on_sheet: true so
the transcription still distinguishes a printed NO from a confirmed one.
No marker changes: those five lights already marked as
new-secondary-cable-only, which is what base NO implies.

Co-Authored-By: Claude Opus 5 <noreply@anthropic.com>
Claude-Session: https://claude.ai/code/session_01SbAnY971yb6vLr9HwCWS8k
</commit_message>
<xml_diff>
--- a/skills/zia-mta-basemap/examples/twy-e-asbuilt-ducts/fieldsheet/TWY_E_AGL_Shop_Drawing_ZIA_P07.pptx
+++ b/skills/zia-mta-basemap/examples/twy-e-asbuilt-ducts/fieldsheet/TWY_E_AGL_Shop_Drawing_ZIA_P07.pptx
@@ -16092,7 +16092,7 @@
                 <a:ea typeface="Arial" pitchFamily="34" charset="-122"/>
                 <a:cs typeface="Arial" pitchFamily="34" charset="-120"/>
               </a:rPr>
-              <a:t>SHALLOW BASE COLUMN LEFT BLANK ON FIELD SHEET — READ AS NOT AFFECTED; NO ASSET LIES INSIDE THE MILLING POLYGON. CONFIRM AT CUT LINE</a:t>
+              <a:t>NO SHALLOW BASES AFFECTED — COLUMN BLANK ON FIELD SHEET, CONFIRMED ‘NO’ 30.07.2026; NO ASSET LIES INSIDE THE MILLING POLYGON</a:t>
             </a:r>
             <a:endParaRPr lang="en-US" sz="760" dirty="0"/>
           </a:p>
@@ -16303,7 +16303,7 @@
                 </a:solidFill>
                 <a:latin typeface="Arial"/>
               </a:rPr>
-              <a:t>6. Rev P07: every asset on this sheet re-marked directly from field sheet Second_milling_area rev _1 (2nd table) — outer ring from the Secondary-cable / Shallow-base columns, inner disc from Duct / Sawcut. Assets not listed on the field sheet are shown grey with no action assumed.</a:t>
+              <a:t>6. Rev P07: every asset on this sheet re-marked directly from field sheet Second_milling_area rev _1 (2nd table) — outer ring from the Secondary-cable / Shallow-base columns, inner disc from Duct / Sawcut. Assets not listed on the field sheet are shown grey with no action assumed. Shallow-base column blank on that sheet; confirmed ‘NO’ 30.07.2026.</a:t>
             </a:r>
           </a:p>
         </p:txBody>

</xml_diff>